<commit_message>
Feinschliff an Report und Präsentation vor der Abgabe
- Vergleichsmenge Blech 8 mm im Report vereinheitlicht (2.260,8 kg)
- Prozentangabe zum Vergabevorteil korrigiert (3,7 statt 3,8 Prozent),
  in Report Kap. 8 sowie Präsentation Folie 7 (Folie und Sprechernotiz)
- Präsentation Folie 9: Preisspiegel-Werte für Klöckner/Salzgitter bei
  Blech 15 mm von "–" auf "0,00 €" geändert, passend zur Sprechernotiz
- Präsentation Folie 13: Hinweis ergänzt, dass die vier Kennzahlen
  unterschiedliche Bezugsgrößen haben und nicht addierbar sind
- Präsentation Sprechernotizen: Vorgangsnummer auf AF-103134-2000
  vereinheitlicht (Folie 1 und 5)

Co-Authored-By: Claude Sonnet 5 <noreply@anthropic.com>
Claude-Session: https://claude.ai/code/session_011eo8Sh8s17fDiLfoEt1XnG
</commit_message>
<xml_diff>
--- a/praesentation/Praesentation_Fachaufgabe_METALLART.pptx
+++ b/praesentation/Praesentation_Fachaufgabe_METALLART.pptx
@@ -517,7 +517,7 @@
             <a:r>
               <a:rPr lang="en-US" dirty="0"/>
               <a:t>Guten Tag. Mein Name ist Alex Urban, ich bin Auszubildender zum Industriekaufmann bei der METALLART Treppen GmbH in Salach, mein Einsatzgebiet ist der Einkauf.
-Ich stelle Ihnen heute die Beschaffung von Grobblechen für unsere Laserfertigung vor, den Vorgang AF-103134 vom August. Interessant ist er, weil das rechnerisch günstigste Angebot am Ende genau das war, das wir nicht bestellen konnten, und weil uns mitten im Vorgang ein Lieferant ausgefallen ist.
+Ich stelle Ihnen heute die Beschaffung von Grobblechen für unsere Laserfertigung vor, den Vorgang AF-103134-2000 vom August. Interessant ist er, weil das rechnerisch günstigste Angebot am Ende genau das war, das wir nicht bestellen konnten, und weil uns mitten im Vorgang ein Lieferant ausgefallen ist.
 [ca. 0:35]</a:t>
             </a:r>
             <a:endParaRPr lang="en-US" dirty="0"/>
@@ -1509,7 +1509,7 @@
           <a:p>
             <a:r>
               <a:rPr lang="en-US" dirty="0"/>
-              <a:t>Noch am selben Tag ging die Anfrage AF-103134 über sieben Positionen an fünf Stahlhändler, mit Wunschtermin 13. August. Vier haben am selben Tag geantwortet, Sülzle Hagmeyer nicht.
+              <a:t>Noch am selben Tag ging die Anfrage AF-103134-2000 über sieben Positionen an fünf Stahlhändler, mit Wunschtermin 13. August. Vier haben am selben Tag geantwortet, Sülzle Hagmeyer nicht.
 Drei Punkte waren für die Bewertung wichtig.
 Erstens waren alle Angebote ausdrücklich freibleibend, bei Klöckner sogar mit dem Zusatz Zwischenverkauf vorbehalten. Ein freibleibendes Angebot ist keine verbindliche Zusage. Der Vertrag kommt erst mit der Auftragsbestätigung zustande. Dieser Punkt wird gleich noch wichtig.
 Zweitens die Versandbedingungen. Unsere Anfrage geht mit der Lieferbedingung ab Werk raus, die Fracht ist also nicht Teil des Materialpreises. Jeder Händler nennt dann seine eigenen Frachtkosten und Zuschläge, und die sind sehr unterschiedlich.
@@ -1692,7 +1692,7 @@
           <a:lstStyle/>
           <a:p>
             <a:r>
-              <a:t>Klöckner liegt mit 9.451,87 Euro vorn, und zwar nicht nur in der Summe, sondern bei jeder einzelnen der fünf Positionen. Zum zweitbesten Anbieter sind es 359,49 Euro Unterschied, also 3,8 Prozent, zum teuersten 703,89 Euro.</a:t>
+              <a:t>Klöckner liegt mit 9.451,87 Euro vorn, und zwar nicht nur in der Summe, sondern bei jeder einzelnen der fünf Positionen. Zum zweitbesten Anbieter sind es 359,49 Euro Unterschied, also 3,7 Prozent, zum teuersten 703,89 Euro.</a:t>
             </a:r>
           </a:p>
           <a:p/>
@@ -5879,7 +5879,7 @@
                 <a:ea typeface="Calibri" pitchFamily="34" charset="-122"/>
                 <a:cs typeface="Calibri" pitchFamily="34" charset="-120"/>
               </a:rPr>
-              <a:t>Ein Stillstand am Laser hätte ein Vielfaches gekostet. Bei der Rechnungsprüfung lag Klöckner 194,20 Euro über der Auftragsbestätigung, gedeckt durch die Abrechnung nach verwogenem Gewicht.</a:t>
+              <a:t>Ein Stillstand am Laser hätte ein Vielfaches gekostet. Die vier Werte oben haben unterschiedliche Bezugsgrößen und sind nicht direkt addierbar.</a:t>
             </a:r>
             <a:endParaRPr lang="en-US" sz="1050" dirty="0"/>
           </a:p>
@@ -13788,7 +13788,7 @@
                 <a:ea typeface="Calibri" pitchFamily="34" charset="-122"/>
                 <a:cs typeface="Calibri" pitchFamily="34" charset="-120"/>
               </a:rPr>
-              <a:t>359,49 Euro günstiger als der zweitbeste Anbieter, das sind 3,8 Prozent.</a:t>
+              <a:t>359,49 Euro günstiger als der zweitbeste Anbieter, das sind 3,7 Prozent.</a:t>
             </a:r>
             <a:endParaRPr lang="en-US" sz="1250" dirty="0"/>
           </a:p>
@@ -15184,7 +15184,7 @@
                           <a:ea typeface="Calibri" pitchFamily="34" charset="-122"/>
                           <a:cs typeface="Calibri" pitchFamily="34" charset="-120"/>
                         </a:rPr>
-                        <a:t>–</a:t>
+                        <a:t>0,00</a:t>
                       </a:r>
                       <a:endParaRPr lang="en-US" sz="1100" dirty="0">
                         <a:latin typeface="Calibri" charset="0"/>
@@ -15541,7 +15541,7 @@
                           <a:ea typeface="Calibri" pitchFamily="34" charset="-122"/>
                           <a:cs typeface="Calibri" pitchFamily="34" charset="-120"/>
                         </a:rPr>
-                        <a:t>–</a:t>
+                        <a:t>0,00</a:t>
                       </a:r>
                       <a:endParaRPr lang="en-US" sz="1100" dirty="0">
                         <a:latin typeface="Calibri" charset="0"/>

</xml_diff>